<commit_message>
Modified based on comments
</commit_message>
<xml_diff>
--- a/Slides/QLS-MiCM_DataVisualizationInPython.pptx
+++ b/Slides/QLS-MiCM_DataVisualizationInPython.pptx
@@ -232,7 +232,7 @@
           <a:p>
             <a:fld id="{9FF74AA5-8A3E-4FDB-94BB-BF4B31CB4E38}" type="datetimeFigureOut">
               <a:rPr lang="en-CA" smtClean="0"/>
-              <a:t>2026-10-19</a:t>
+              <a:t>2026-10-25</a:t>
             </a:fld>
             <a:endParaRPr lang="en-CA"/>
           </a:p>
@@ -409,7 +409,7 @@
           <a:p>
             <a:fld id="{217E5156-1B5D-054E-B5B2-E1B1BA160252}" type="datetimeFigureOut">
               <a:rPr lang="fr-FR" smtClean="0"/>
-              <a:t>19/10/2026</a:t>
+              <a:t>25/10/2026</a:t>
             </a:fld>
             <a:endParaRPr lang="fr-FR"/>
           </a:p>
@@ -782,6 +782,7 @@
           <a:lstStyle/>
           <a:p>
             <a:r>
+              <a:rPr dirty="0"/>
               <a:t>Wide = how data are usually stored; long = how Seaborn wants them: one row per observation, columns map to x, y, hue, col.</a:t>
             </a:r>
           </a:p>
@@ -852,7 +853,16 @@
           <a:lstStyle/>
           <a:p>
             <a:r>
-              <a:t>Good/bad practice preview for Day 3. Weissgerber et al. 2015 (PLoS Biol) 'Beyond bar and line graphs' is a good reference.</a:t>
+              <a:rPr dirty="0"/>
+              <a:t>Good/bad practice preview for Day 3. Weissgerber et al. 2015 (</a:t>
+            </a:r>
+            <a:r>
+              <a:rPr dirty="0" err="1"/>
+              <a:t>PLoS</a:t>
+            </a:r>
+            <a:r>
+              <a:rPr dirty="0"/>
+              <a:t> Biol) 'Beyond bar and line graphs' is a good reference.</a:t>
             </a:r>
           </a:p>
         </p:txBody>
@@ -922,6 +932,7 @@
           <a:lstStyle/>
           <a:p>
             <a:r>
+              <a:rPr dirty="0"/>
               <a:t>Cornea CoV2 vs mock. Top genes are NF-kB targets (SOD2, C3, TNFAIP3, CXCL1) — matches the paper's inflammatory signature.</a:t>
             </a:r>
           </a:p>
@@ -992,7 +1003,24 @@
           <a:lstStyle/>
           <a:p>
             <a:r>
-              <a:t>Rainbow/jet is not perceptually uniform and is unreadable for colour-blind readers (Crameri et al. 2020, Nat Commun).</a:t>
+              <a:rPr dirty="0"/>
+              <a:t>Rainbow/jet is not perceptually uniform and is unreadable for </a:t>
+            </a:r>
+            <a:r>
+              <a:rPr dirty="0" err="1"/>
+              <a:t>colour</a:t>
+            </a:r>
+            <a:r>
+              <a:rPr dirty="0"/>
+              <a:t>-blind readers (</a:t>
+            </a:r>
+            <a:r>
+              <a:rPr dirty="0" err="1"/>
+              <a:t>Crameri</a:t>
+            </a:r>
+            <a:r>
+              <a:rPr dirty="0"/>
+              <a:t> et al. 2020, Nat Commun).</a:t>
             </a:r>
           </a:p>
         </p:txBody>
@@ -1062,7 +1090,16 @@
           <a:lstStyle/>
           <a:p>
             <a:r>
-              <a:t>Keep the maths light. Point out that tissue dominates PC1/PC2; the notebook's within-tissue PCA shows infection on PC1. Message: PCA is the default for bulk data; t-SNE/UMAP are for many points (single cell) and are sensitive to parameters — Exercise 5 shows this. Always set and report the random seed.</a:t>
+              <a:rPr dirty="0"/>
+              <a:t>Keep the </a:t>
+            </a:r>
+            <a:r>
+              <a:rPr dirty="0" err="1"/>
+              <a:t>maths</a:t>
+            </a:r>
+            <a:r>
+              <a:rPr dirty="0"/>
+              <a:t> light. Point out that tissue dominates PC1/PC2; the notebook's within-tissue PCA shows infection on PC1. Message: PCA is the default for bulk data; t-SNE/UMAP are for many points (single cell) and are sensitive to parameters — Exercise 5 shows this. Always set and report the random seed.</a:t>
             </a:r>
           </a:p>
         </p:txBody>
@@ -1132,7 +1169,16 @@
           <a:lstStyle/>
           <a:p>
             <a:r>
-              <a:t>On Colab, files in figures/ vanish when the session ends: run the download cell. Never screenshot a plot for a paper. Keep the exported PDF/SVG: participants bring it to Day 4 (Inkscape).</a:t>
+              <a:rPr dirty="0"/>
+              <a:t>On </a:t>
+            </a:r>
+            <a:r>
+              <a:rPr dirty="0" err="1"/>
+              <a:t>Colab</a:t>
+            </a:r>
+            <a:r>
+              <a:rPr dirty="0"/>
+              <a:t>, files in figures/ vanish when the session ends: run the download cell. Never screenshot a plot for a paper. Keep the exported PDF/SVG: participants bring it to Day 4 (Inkscape).</a:t>
             </a:r>
           </a:p>
         </p:txBody>
@@ -1202,6 +1248,7 @@
           <a:lstStyle/>
           <a:p>
             <a:r>
+              <a:rPr dirty="0"/>
               <a:t>This checklist is also at the end of the notebook. We'll build on it on Day 3 (good vs bad practices).</a:t>
             </a:r>
           </a:p>
@@ -1272,6 +1319,7 @@
           <a:lstStyle/>
           <a:p>
             <a:r>
+              <a:rPr dirty="0"/>
               <a:t>Remind participants to fill the Day 3 registration question about their data type.</a:t>
             </a:r>
           </a:p>
@@ -1790,7 +1838,16 @@
           <a:lstStyle/>
           <a:p>
             <a:r>
-              <a:t>Give everyone 3–4 minutes to open Colab and run the setup cell. Local Jupyter works too: clone the repo and run from Exercises/scripts.</a:t>
+              <a:rPr dirty="0"/>
+              <a:t>Give everyone 3–4 minutes to open </a:t>
+            </a:r>
+            <a:r>
+              <a:rPr dirty="0" err="1"/>
+              <a:t>Colab</a:t>
+            </a:r>
+            <a:r>
+              <a:rPr dirty="0"/>
+              <a:t> and run the setup cell. Local Jupyter works too: clone the repo and run from Exercises/scripts.</a:t>
             </a:r>
           </a:p>
         </p:txBody>
@@ -1860,7 +1917,16 @@
           <a:lstStyle/>
           <a:p>
             <a:r>
-              <a:t>Key idea of the day. Every element of a plot is an object you can modify. Always use fig, ax = plt.subplots(); this pays off when building multi-panel figures in Module 6.</a:t>
+              <a:rPr dirty="0"/>
+              <a:t>Key idea of the day. Every element of a plot is an object you can modify. Always use fig, ax = </a:t>
+            </a:r>
+            <a:r>
+              <a:rPr dirty="0" err="1"/>
+              <a:t>plt.subplots</a:t>
+            </a:r>
+            <a:r>
+              <a:rPr dirty="0"/>
+              <a:t>(); this pays off when building multi-panel figures in Module 6.</a:t>
             </a:r>
           </a:p>
         </p:txBody>
@@ -8025,7 +8091,13 @@
       </p:sp>
       <p:pic>
         <p:nvPicPr>
-          <p:cNvPr id="4" name="Picture 3" descr="feedback-qr.png"/>
+          <p:cNvPr id="6" name="Picture 5">
+            <a:extLst>
+              <a:ext uri="{FF2B5EF4-FFF2-40B4-BE49-F238E27FC236}">
+                <a16:creationId xmlns:a16="http://schemas.microsoft.com/office/drawing/2014/main" id="{5C4B00F5-4E23-01C0-17B6-C028926B66C2}"/>
+              </a:ext>
+            </a:extLst>
+          </p:cNvPr>
           <p:cNvPicPr>
             <a:picLocks noChangeAspect="1"/>
           </p:cNvPicPr>
@@ -8039,8 +8111,8 @@
         </p:blipFill>
         <p:spPr>
           <a:xfrm>
-            <a:off x="3136900" y="1993900"/>
-            <a:ext cx="2870200" cy="2870200"/>
+            <a:off x="2669702" y="1430981"/>
+            <a:ext cx="3804596" cy="3804596"/>
           </a:xfrm>
           <a:prstGeom prst="rect">
             <a:avLst/>
@@ -8095,8 +8167,8 @@
         </p:nvSpPr>
         <p:spPr>
           <a:xfrm>
-            <a:off x="924887" y="5287892"/>
-            <a:ext cx="3224152" cy="646331"/>
+            <a:off x="1459969" y="5396173"/>
+            <a:ext cx="6224058" cy="646331"/>
           </a:xfrm>
         </p:spPr>
         <p:txBody>
@@ -8201,96 +8273,6 @@
           </a:prstGeom>
         </p:spPr>
       </p:pic>
-      <p:pic>
-        <p:nvPicPr>
-          <p:cNvPr id="12" name="Picture 11" descr="A qr code with black squares&#10;&#10;Description automatically generated">
-            <a:extLst>
-              <a:ext uri="{FF2B5EF4-FFF2-40B4-BE49-F238E27FC236}">
-                <a16:creationId xmlns:a16="http://schemas.microsoft.com/office/drawing/2014/main" id="{333BAB40-358F-BE60-7494-578A1971B335}"/>
-              </a:ext>
-            </a:extLst>
-          </p:cNvPr>
-          <p:cNvPicPr>
-            <a:picLocks noChangeAspect="1"/>
-          </p:cNvPicPr>
-          <p:nvPr/>
-        </p:nvPicPr>
-        <p:blipFill>
-          <a:blip r:embed="rId4"/>
-          <a:stretch>
-            <a:fillRect/>
-          </a:stretch>
-        </p:blipFill>
-        <p:spPr>
-          <a:xfrm>
-            <a:off x="5518580" y="2808275"/>
-            <a:ext cx="2203814" cy="2203814"/>
-          </a:xfrm>
-          <a:prstGeom prst="rect">
-            <a:avLst/>
-          </a:prstGeom>
-        </p:spPr>
-      </p:pic>
-      <p:sp>
-        <p:nvSpPr>
-          <p:cNvPr id="13" name="TextBox 12">
-            <a:extLst>
-              <a:ext uri="{FF2B5EF4-FFF2-40B4-BE49-F238E27FC236}">
-                <a16:creationId xmlns:a16="http://schemas.microsoft.com/office/drawing/2014/main" id="{174C1E59-2F37-F73C-4DFA-8971D19A54AE}"/>
-              </a:ext>
-            </a:extLst>
-          </p:cNvPr>
-          <p:cNvSpPr txBox="1"/>
-          <p:nvPr/>
-        </p:nvSpPr>
-        <p:spPr>
-          <a:xfrm>
-            <a:off x="4373913" y="5288330"/>
-            <a:ext cx="4632294" cy="646331"/>
-          </a:xfrm>
-          <a:prstGeom prst="rect">
-            <a:avLst/>
-          </a:prstGeom>
-          <a:noFill/>
-        </p:spPr>
-        <p:txBody>
-          <a:bodyPr wrap="square" lIns="91440" tIns="45720" rIns="91440" bIns="45720" rtlCol="0" anchor="t">
-            <a:spAutoFit/>
-          </a:bodyPr>
-          <a:lstStyle/>
-          <a:p>
-            <a:pPr algn="ctr"/>
-            <a:r>
-              <a:rPr lang="en-CA" sz="1800" dirty="0">
-                <a:latin typeface="Helvetica" panose="020B0604020202020204" pitchFamily="34" charset="0"/>
-                <a:cs typeface="Helvetica" panose="020B0604020202020204" pitchFamily="34" charset="0"/>
-              </a:rPr>
-              <a:t>Scan the QR code to sign up </a:t>
-            </a:r>
-          </a:p>
-          <a:p>
-            <a:pPr algn="ctr"/>
-            <a:r>
-              <a:rPr lang="en-CA" sz="1800" dirty="0">
-                <a:latin typeface="Helvetica" panose="020B0604020202020204" pitchFamily="34" charset="0"/>
-                <a:cs typeface="Helvetica" panose="020B0604020202020204" pitchFamily="34" charset="0"/>
-              </a:rPr>
-              <a:t>for our </a:t>
-            </a:r>
-            <a:r>
-              <a:rPr lang="en-CA" sz="1800" b="1" dirty="0">
-                <a:latin typeface="Helvetica" panose="020B0604020202020204" pitchFamily="34" charset="0"/>
-                <a:cs typeface="Helvetica" panose="020B0604020202020204" pitchFamily="34" charset="0"/>
-              </a:rPr>
-              <a:t>mailing list</a:t>
-            </a:r>
-            <a:endParaRPr lang="en-CA" sz="1800" dirty="0">
-              <a:latin typeface="Helvetica" panose="020B0604020202020204" pitchFamily="34" charset="0"/>
-              <a:cs typeface="Helvetica" panose="020B0604020202020204" pitchFamily="34" charset="0"/>
-            </a:endParaRPr>
-          </a:p>
-        </p:txBody>
-      </p:sp>
       <p:sp>
         <p:nvSpPr>
           <p:cNvPr id="3" name="TextBox 2">
@@ -8327,23 +8309,33 @@
                 <a:latin typeface="Helvetica" panose="020B0604020202020204" pitchFamily="34" charset="0"/>
                 <a:cs typeface="Helvetica" panose="020B0604020202020204" pitchFamily="34" charset="0"/>
               </a:rPr>
-              <a:t>Contact: </a:t>
+              <a:t>https://</a:t>
+            </a:r>
+            <a:r>
+              <a:rPr lang="en-CA" sz="1800" dirty="0" err="1">
+                <a:latin typeface="Helvetica" panose="020B0604020202020204" pitchFamily="34" charset="0"/>
+                <a:cs typeface="Helvetica" panose="020B0604020202020204" pitchFamily="34" charset="0"/>
+              </a:rPr>
+              <a:t>www.mcgill.ca</a:t>
             </a:r>
             <a:r>
               <a:rPr lang="en-CA" sz="1800" dirty="0">
                 <a:latin typeface="Helvetica" panose="020B0604020202020204" pitchFamily="34" charset="0"/>
                 <a:cs typeface="Helvetica" panose="020B0604020202020204" pitchFamily="34" charset="0"/>
-                <a:hlinkClick r:id="rId5"/>
-              </a:rPr>
-              <a:t>workshop-micm@mcgill.ca</a:t>
-            </a:r>
-            <a:r>
-              <a:rPr lang="en-CA" sz="1800" dirty="0">
+              </a:rPr>
+              <a:t>/</a:t>
+            </a:r>
+            <a:r>
+              <a:rPr lang="en-CA" sz="1800">
                 <a:latin typeface="Helvetica" panose="020B0604020202020204" pitchFamily="34" charset="0"/>
                 <a:cs typeface="Helvetica" panose="020B0604020202020204" pitchFamily="34" charset="0"/>
               </a:rPr>
-              <a:t> </a:t>
-            </a:r>
+              <a:t>micm</a:t>
+            </a:r>
+            <a:endParaRPr lang="en-CA" sz="1800" dirty="0">
+              <a:latin typeface="Helvetica" panose="020B0604020202020204" pitchFamily="34" charset="0"/>
+              <a:cs typeface="Helvetica" panose="020B0604020202020204" pitchFamily="34" charset="0"/>
+            </a:endParaRPr>
           </a:p>
         </p:txBody>
       </p:sp>
@@ -8362,24 +8354,28 @@
           <p:nvPr/>
         </p:nvPicPr>
         <p:blipFill>
-          <a:blip r:embed="rId6"/>
+          <a:blip r:embed="rId4"/>
           <a:stretch>
             <a:fillRect/>
           </a:stretch>
         </p:blipFill>
         <p:spPr>
           <a:xfrm>
-            <a:off x="924887" y="2649379"/>
+            <a:off x="3137753" y="2519758"/>
             <a:ext cx="2868491" cy="2356534"/>
           </a:xfrm>
-          <a:prstGeom prst="ellipse">
+          <a:prstGeom prst="rect">
             <a:avLst/>
           </a:prstGeom>
           <a:ln>
             <a:noFill/>
           </a:ln>
           <a:effectLst>
-            <a:softEdge rad="112500"/>
+            <a:outerShdw blurRad="292100" dist="139700" dir="2700000" algn="tl" rotWithShape="0">
+              <a:srgbClr val="333333">
+                <a:alpha val="65000"/>
+              </a:srgbClr>
+            </a:outerShdw>
           </a:effectLst>
         </p:spPr>
       </p:pic>
@@ -13535,30 +13531,6 @@
           </a:p>
         </p:txBody>
       </p:sp>
-      <p:pic>
-        <p:nvPicPr>
-          <p:cNvPr id="3" name="Picture 2" descr="qr_repo.png"/>
-          <p:cNvPicPr>
-            <a:picLocks noChangeAspect="1"/>
-          </p:cNvPicPr>
-          <p:nvPr/>
-        </p:nvPicPr>
-        <p:blipFill>
-          <a:blip r:embed="rId3"/>
-          <a:stretch>
-            <a:fillRect/>
-          </a:stretch>
-        </p:blipFill>
-        <p:spPr>
-          <a:xfrm>
-            <a:off x="640080" y="1280160"/>
-            <a:ext cx="2377440" cy="2377440"/>
-          </a:xfrm>
-          <a:prstGeom prst="rect">
-            <a:avLst/>
-          </a:prstGeom>
-        </p:spPr>
-      </p:pic>
       <p:sp>
         <p:nvSpPr>
           <p:cNvPr id="4" name="TextBox 3"/>
@@ -13567,8 +13539,8 @@
         </p:nvSpPr>
         <p:spPr>
           <a:xfrm>
-            <a:off x="411480" y="3703320"/>
-            <a:ext cx="2834640" cy="548640"/>
+            <a:off x="346017" y="3736571"/>
+            <a:ext cx="2965565" cy="769441"/>
           </a:xfrm>
           <a:prstGeom prst="rect">
             <a:avLst/>
@@ -13587,44 +13559,61 @@
               </a:spcAft>
             </a:pPr>
             <a:r>
-              <a:rPr sz="1100" b="0" i="0">
+              <a:rPr lang="en-CA" sz="1100" dirty="0">
                 <a:solidFill>
                   <a:srgbClr val="222222"/>
                 </a:solidFill>
                 <a:latin typeface="Courier New"/>
               </a:rPr>
-              <a:t>github.com/QLS-MiCM/</a:t>
-            </a:r>
-          </a:p>
-          <a:p>
-            <a:pPr algn="ctr">
-              <a:spcAft>
-                <a:spcPts val="0"/>
-              </a:spcAft>
-            </a:pPr>
-            <a:r>
-              <a:rPr sz="1100" b="0" i="0">
+              <a:t>QLS-</a:t>
+            </a:r>
+            <a:r>
+              <a:rPr lang="en-CA" sz="1100" dirty="0" err="1">
                 <a:solidFill>
                   <a:srgbClr val="222222"/>
                 </a:solidFill>
                 <a:latin typeface="Courier New"/>
               </a:rPr>
-              <a:t>DataVisualizationInPython</a:t>
-            </a:r>
+              <a:t>MiCM</a:t>
+            </a:r>
+            <a:r>
+              <a:rPr lang="en-CA" sz="1100" dirty="0">
+                <a:solidFill>
+                  <a:srgbClr val="222222"/>
+                </a:solidFill>
+                <a:latin typeface="Courier New"/>
+              </a:rPr>
+              <a:t>/Fall-2026-Bootcamp-Data-Visualization-in-Python/blob/main/Exercises/scripts/</a:t>
+            </a:r>
+            <a:r>
+              <a:rPr lang="en-CA" sz="1100" dirty="0" err="1">
+                <a:solidFill>
+                  <a:srgbClr val="222222"/>
+                </a:solidFill>
+                <a:latin typeface="Courier New"/>
+              </a:rPr>
+              <a:t>DataVisualizationInPython.ipynb</a:t>
+            </a:r>
+            <a:endParaRPr sz="1100" b="0" i="0" dirty="0">
+              <a:solidFill>
+                <a:srgbClr val="222222"/>
+              </a:solidFill>
+              <a:latin typeface="Courier New"/>
+            </a:endParaRPr>
           </a:p>
         </p:txBody>
       </p:sp>
       <p:sp>
         <p:nvSpPr>
           <p:cNvPr id="5" name="Rounded Rectangle 4">
-            <a:hlinkClick r:id="rId4"/>
+            <a:hlinkClick r:id="rId3"/>
           </p:cNvPr>
           <p:cNvSpPr/>
           <p:nvPr/>
         </p:nvSpPr>
         <p:spPr>
           <a:xfrm>
-            <a:off x="685800" y="4343400"/>
+            <a:off x="685800" y="4626864"/>
             <a:ext cx="2286000" cy="548640"/>
           </a:xfrm>
           <a:prstGeom prst="roundRect">
@@ -13664,14 +13653,16 @@
       </p:sp>
       <p:sp>
         <p:nvSpPr>
-          <p:cNvPr id="6" name="TextBox 5"/>
+          <p:cNvPr id="6" name="TextBox 5">
+            <a:hlinkClick r:id="rId4"/>
+          </p:cNvPr>
           <p:cNvSpPr txBox="1"/>
           <p:nvPr/>
         </p:nvSpPr>
         <p:spPr>
           <a:xfrm>
-            <a:off x="685800" y="4407408"/>
-            <a:ext cx="2286000" cy="411480"/>
+            <a:off x="685800" y="4723292"/>
+            <a:ext cx="2286000" cy="338554"/>
           </a:xfrm>
           <a:prstGeom prst="rect">
             <a:avLst/>
@@ -13690,13 +13681,28 @@
               </a:spcAft>
             </a:pPr>
             <a:r>
-              <a:rPr sz="1600" b="1" i="0">
+              <a:rPr sz="1600" b="1" i="0" dirty="0">
                 <a:solidFill>
                   <a:srgbClr val="FFFFFF"/>
                 </a:solidFill>
-              </a:rPr>
-              <a:t>▶  Open in Colab</a:t>
-            </a:r>
+                <a:hlinkClick r:id="rId5"/>
+              </a:rPr>
+              <a:t>▶  Open in </a:t>
+            </a:r>
+            <a:r>
+              <a:rPr sz="1600" b="1" i="0" dirty="0" err="1">
+                <a:solidFill>
+                  <a:srgbClr val="FFFFFF"/>
+                </a:solidFill>
+                <a:hlinkClick r:id="rId5"/>
+              </a:rPr>
+              <a:t>Colab</a:t>
+            </a:r>
+            <a:endParaRPr sz="1600" b="1" i="0" dirty="0">
+              <a:solidFill>
+                <a:srgbClr val="FFFFFF"/>
+              </a:solidFill>
+            </a:endParaRPr>
           </a:p>
         </p:txBody>
       </p:sp>
@@ -14240,6 +14246,36 @@
           </a:p>
         </p:txBody>
       </p:sp>
+      <p:pic>
+        <p:nvPicPr>
+          <p:cNvPr id="22" name="Picture 21">
+            <a:extLst>
+              <a:ext uri="{FF2B5EF4-FFF2-40B4-BE49-F238E27FC236}">
+                <a16:creationId xmlns:a16="http://schemas.microsoft.com/office/drawing/2014/main" id="{FEDB6C70-E7C1-568F-EE6D-52C41DBFCA08}"/>
+              </a:ext>
+            </a:extLst>
+          </p:cNvPr>
+          <p:cNvPicPr>
+            <a:picLocks noChangeAspect="1"/>
+          </p:cNvPicPr>
+          <p:nvPr/>
+        </p:nvPicPr>
+        <p:blipFill>
+          <a:blip r:embed="rId6"/>
+          <a:stretch>
+            <a:fillRect/>
+          </a:stretch>
+        </p:blipFill>
+        <p:spPr>
+          <a:xfrm>
+            <a:off x="411480" y="901931"/>
+            <a:ext cx="2834640" cy="2834640"/>
+          </a:xfrm>
+          <a:prstGeom prst="rect">
+            <a:avLst/>
+          </a:prstGeom>
+        </p:spPr>
+      </p:pic>
     </p:spTree>
   </p:cSld>
   <p:clrMapOvr>

</xml_diff>